<commit_message>
Apply real farm figures: Jersey-only herd, 70 head
목장 실측 제원을 발표자료에 반영하고, 저지 단일 품종 사실을 컨텍스트에 고정.

슬라이드 6을 플레이스홀더에서 실측치로 교체:
총 70두(착유 35 / 건유·초임만삭 10 / 송아지·육성우 25),
축사 2,000㎡, 퇴비장 450㎡, 유가공장 시간당 500L.
착유 35두 소규모임을 먼저 인정하고, 그래서 유가공·순환 구조가
필수였다는 논리로 잇는 요약 밴드 추가.

홀스타인 보유를 전제한 표현 정정:
- 슬라이드 2 목장 소개 '저지·홀스타인 사육' → '저지종 단일 품종 사육'
- 슬라이드 14 '수란우(홀스타인)' → 품종 특정 없이 '수란우'
- 슬라이드 44 제공 항목 '저지·홀스타인 축군' → '저지종 단일 축군 70두'
(슬라이드 10·11의 저지 vs 홀스타인 비교는 품종 참고 비교이므로 유지)

context/songyoungshin-growth-context.md에 Farm profile 절 신설 —
저지 단일 품종임을 명시하고 두수·면적·처리용량을 표로 고정.
두당 유량·유성분은 미확보로 표기해 임의 생성을 차단.

Co-Authored-By: Claude Opus 5 <noreply@anthropic.com>
Claude-Session: https://claude.ai/code/session_012dh73XSbpTomn1pD8MAo7i
</commit_message>
<xml_diff>
--- a/deliverables/2026-08-10-nias-seminar/저지종_유가공목장_운영_현장사례.pptx
+++ b/deliverables/2026-08-10-nias-seminar/저지종_유가공목장_운영_현장사례.pptx
@@ -4934,7 +4934,7 @@
           <a:p>
             <a:r>
               <a:rPr lang="en-US" dirty="0"/>
-              <a:t>실측치를 채워 발표. 특히 두당 유량과 유성분은 반드시 실제 검정 성적으로 말할 것. 청중이 연구·지도 인력이므로 근거 없는 수치는 바로 신뢰를 잃는다.</a:t>
+              <a:t>착유 35두 소규모임을 먼저 인정하고 시작한다. 규모가 작아서 오히려 유가공·직판이 필수였다는 논리로 연결. 두당 유량·유성분 검정 성적을 말할 수 있으면 여기서 구두로 덧붙인다.</a:t>
             </a:r>
             <a:endParaRPr lang="en-US" dirty="0"/>
           </a:p>
@@ -11741,7 +11741,7 @@
                 <a:ea typeface="Malgun Gothic" pitchFamily="34" charset="-122"/>
                 <a:cs typeface="Malgun Gothic" pitchFamily="34" charset="-120"/>
               </a:rPr>
-              <a:t>수란우(홀스타인)를 활용해 기존 사육 자원을 그대로 씁니다</a:t>
+              <a:t>수란우를 활용하므로 기존 축군을 그대로 증식 자원으로 씁니다</a:t>
             </a:r>
             <a:endParaRPr lang="en-US" sz="1350" dirty="0"/>
           </a:p>
@@ -16073,7 +16073,7 @@
                 <a:ea typeface="Malgun Gothic" pitchFamily="34" charset="-122"/>
                 <a:cs typeface="Malgun Gothic" pitchFamily="34" charset="-120"/>
               </a:rPr>
-              <a:t>저지·홀스타인 사육</a:t>
+              <a:t>저지종 단일 품종 사육</a:t>
             </a:r>
             <a:endParaRPr lang="en-US" sz="1250" dirty="0"/>
           </a:p>
@@ -41042,7 +41042,7 @@
                 <a:ea typeface="Malgun Gothic" pitchFamily="34" charset="-122"/>
                 <a:cs typeface="Malgun Gothic" pitchFamily="34" charset="-120"/>
               </a:rPr>
-              <a:t>저지·홀스타인 축군과 개체별 사육·번식 이력</a:t>
+              <a:t>저지종 단일 축군 70두의 개체별 사육·번식 이력</a:t>
             </a:r>
             <a:endParaRPr lang="en-US" sz="1300" dirty="0"/>
           </a:p>
@@ -43198,7 +43198,7 @@
                 <a:ea typeface="Malgun Gothic" pitchFamily="34" charset="-122"/>
                 <a:cs typeface="Malgun Gothic" pitchFamily="34" charset="-120"/>
               </a:rPr>
-              <a:t>목장 개요</a:t>
+              <a:t>목장 개요 — 저지종 단일 품종, 총 70두</a:t>
             </a:r>
             <a:endParaRPr lang="en-US" sz="3000" dirty="0"/>
           </a:p>
@@ -43212,12 +43212,12 @@
         </p:nvSpPr>
         <p:spPr>
           <a:xfrm>
-            <a:off x="566928" y="1325880"/>
-            <a:ext cx="3547872" cy="1920240"/>
+            <a:off x="566928" y="1298448"/>
+            <a:ext cx="2633472" cy="1600200"/>
           </a:xfrm>
           <a:prstGeom prst="roundRect">
             <a:avLst>
-              <a:gd name="adj" fmla="val 4762"/>
+              <a:gd name="adj" fmla="val 5714"/>
             </a:avLst>
           </a:prstGeom>
           <a:solidFill>
@@ -43234,8 +43234,8 @@
         </p:nvSpPr>
         <p:spPr>
           <a:xfrm>
-            <a:off x="566928" y="1490472"/>
-            <a:ext cx="3547872" cy="658368"/>
+            <a:off x="566928" y="1463040"/>
+            <a:ext cx="2633472" cy="658368"/>
           </a:xfrm>
           <a:prstGeom prst="rect">
             <a:avLst/>
@@ -43259,7 +43259,7 @@
                 <a:ea typeface="Malgun Gothic" pitchFamily="34" charset="-122"/>
                 <a:cs typeface="Malgun Gothic" pitchFamily="34" charset="-120"/>
               </a:rPr>
-              <a:t>[  ]두</a:t>
+              <a:t>70두</a:t>
             </a:r>
             <a:endParaRPr lang="en-US" sz="3200" dirty="0"/>
           </a:p>
@@ -43273,8 +43273,8 @@
         </p:nvSpPr>
         <p:spPr>
           <a:xfrm>
-            <a:off x="658368" y="2167128"/>
-            <a:ext cx="3364992" cy="987552"/>
+            <a:off x="658368" y="2139696"/>
+            <a:ext cx="2450592" cy="667512"/>
           </a:xfrm>
           <a:prstGeom prst="rect">
             <a:avLst/>
@@ -43315,7 +43315,7 @@
                 <a:ea typeface="Malgun Gothic" pitchFamily="34" charset="-122"/>
                 <a:cs typeface="Malgun Gothic" pitchFamily="34" charset="-120"/>
               </a:rPr>
-              <a:t>(저지 [  ]두 / 홀스타인 [  ]두)</a:t>
+              <a:t>저지종 단일 품종</a:t>
             </a:r>
             <a:endParaRPr lang="en-US" sz="1150" dirty="0"/>
           </a:p>
@@ -43329,12 +43329,12 @@
         </p:nvSpPr>
         <p:spPr>
           <a:xfrm>
-            <a:off x="4315968" y="1325880"/>
-            <a:ext cx="3547872" cy="1920240"/>
+            <a:off x="3401568" y="1298448"/>
+            <a:ext cx="2633472" cy="1600200"/>
           </a:xfrm>
           <a:prstGeom prst="roundRect">
             <a:avLst>
-              <a:gd name="adj" fmla="val 4762"/>
+              <a:gd name="adj" fmla="val 5714"/>
             </a:avLst>
           </a:prstGeom>
           <a:solidFill>
@@ -43351,8 +43351,8 @@
         </p:nvSpPr>
         <p:spPr>
           <a:xfrm>
-            <a:off x="4315968" y="1490472"/>
-            <a:ext cx="3547872" cy="658368"/>
+            <a:off x="3401568" y="1463040"/>
+            <a:ext cx="2633472" cy="658368"/>
           </a:xfrm>
           <a:prstGeom prst="rect">
             <a:avLst/>
@@ -43376,7 +43376,7 @@
                 <a:ea typeface="Malgun Gothic" pitchFamily="34" charset="-122"/>
                 <a:cs typeface="Malgun Gothic" pitchFamily="34" charset="-120"/>
               </a:rPr>
-              <a:t>[  ]두</a:t>
+              <a:t>35두</a:t>
             </a:r>
             <a:endParaRPr lang="en-US" sz="3200" dirty="0"/>
           </a:p>
@@ -43390,8 +43390,8 @@
         </p:nvSpPr>
         <p:spPr>
           <a:xfrm>
-            <a:off x="4407408" y="2167128"/>
-            <a:ext cx="3364992" cy="987552"/>
+            <a:off x="3493008" y="2139696"/>
+            <a:ext cx="2450592" cy="667512"/>
           </a:xfrm>
           <a:prstGeom prst="rect">
             <a:avLst/>
@@ -43415,27 +43415,10 @@
                 <a:ea typeface="Malgun Gothic" pitchFamily="34" charset="-122"/>
                 <a:cs typeface="Malgun Gothic" pitchFamily="34" charset="-120"/>
               </a:rPr>
-              <a:t>착유두수</a:t>
+              <a:t>착유우</a:t>
             </a:r>
             <a:endParaRPr lang="en-US" sz="1150" dirty="0"/>
           </a:p>
-          <a:p>
-            <a:pPr algn="ctr" indent="0" marL="0">
-              <a:buNone/>
-            </a:pPr>
-            <a:r>
-              <a:rPr lang="en-US" sz="1150" dirty="0">
-                <a:solidFill>
-                  <a:srgbClr val="5E6B5F"/>
-                </a:solidFill>
-                <a:latin typeface="Malgun Gothic" pitchFamily="34" charset="0"/>
-                <a:ea typeface="Malgun Gothic" pitchFamily="34" charset="-122"/>
-                <a:cs typeface="Malgun Gothic" pitchFamily="34" charset="-120"/>
-              </a:rPr>
-              <a:t>두당 일 평균 유량 [  ] kg</a:t>
-            </a:r>
-            <a:endParaRPr lang="en-US" sz="1150" dirty="0"/>
-          </a:p>
         </p:txBody>
       </p:sp>
       <p:sp>
@@ -43446,12 +43429,12 @@
         </p:nvSpPr>
         <p:spPr>
           <a:xfrm>
-            <a:off x="8065008" y="1325880"/>
-            <a:ext cx="3547872" cy="1920240"/>
+            <a:off x="6236208" y="1298448"/>
+            <a:ext cx="2633472" cy="1600200"/>
           </a:xfrm>
           <a:prstGeom prst="roundRect">
             <a:avLst>
-              <a:gd name="adj" fmla="val 4762"/>
+              <a:gd name="adj" fmla="val 5714"/>
             </a:avLst>
           </a:prstGeom>
           <a:solidFill>
@@ -43468,8 +43451,8 @@
         </p:nvSpPr>
         <p:spPr>
           <a:xfrm>
-            <a:off x="8065008" y="1490472"/>
-            <a:ext cx="3547872" cy="658368"/>
+            <a:off x="6236208" y="1463040"/>
+            <a:ext cx="2633472" cy="658368"/>
           </a:xfrm>
           <a:prstGeom prst="rect">
             <a:avLst/>
@@ -43493,7 +43476,7 @@
                 <a:ea typeface="Malgun Gothic" pitchFamily="34" charset="-122"/>
                 <a:cs typeface="Malgun Gothic" pitchFamily="34" charset="-120"/>
               </a:rPr>
-              <a:t>[  ]㎡</a:t>
+              <a:t>10두</a:t>
             </a:r>
             <a:endParaRPr lang="en-US" sz="3200" dirty="0"/>
           </a:p>
@@ -43507,8 +43490,8 @@
         </p:nvSpPr>
         <p:spPr>
           <a:xfrm>
-            <a:off x="8156448" y="2167128"/>
-            <a:ext cx="3364992" cy="987552"/>
+            <a:off x="6327648" y="2139696"/>
+            <a:ext cx="2450592" cy="667512"/>
           </a:xfrm>
           <a:prstGeom prst="rect">
             <a:avLst/>
@@ -43532,27 +43515,10 @@
                 <a:ea typeface="Malgun Gothic" pitchFamily="34" charset="-122"/>
                 <a:cs typeface="Malgun Gothic" pitchFamily="34" charset="-120"/>
               </a:rPr>
-              <a:t>축사 면적</a:t>
+              <a:t>건유우 · 초임만삭</a:t>
             </a:r>
             <a:endParaRPr lang="en-US" sz="1150" dirty="0"/>
           </a:p>
-          <a:p>
-            <a:pPr algn="ctr" indent="0" marL="0">
-              <a:buNone/>
-            </a:pPr>
-            <a:r>
-              <a:rPr lang="en-US" sz="1150" dirty="0">
-                <a:solidFill>
-                  <a:srgbClr val="5E6B5F"/>
-                </a:solidFill>
-                <a:latin typeface="Malgun Gothic" pitchFamily="34" charset="0"/>
-                <a:ea typeface="Malgun Gothic" pitchFamily="34" charset="-122"/>
-                <a:cs typeface="Malgun Gothic" pitchFamily="34" charset="-120"/>
-              </a:rPr>
-              <a:t>(HBP 운용 구간 [  ]㎡)</a:t>
-            </a:r>
-            <a:endParaRPr lang="en-US" sz="1150" dirty="0"/>
-          </a:p>
         </p:txBody>
       </p:sp>
       <p:sp>
@@ -43563,12 +43529,12 @@
         </p:nvSpPr>
         <p:spPr>
           <a:xfrm>
-            <a:off x="566928" y="3474720"/>
-            <a:ext cx="3547872" cy="1920240"/>
+            <a:off x="9070848" y="1298448"/>
+            <a:ext cx="2633472" cy="1600200"/>
           </a:xfrm>
           <a:prstGeom prst="roundRect">
             <a:avLst>
-              <a:gd name="adj" fmla="val 4762"/>
+              <a:gd name="adj" fmla="val 5714"/>
             </a:avLst>
           </a:prstGeom>
           <a:solidFill>
@@ -43585,8 +43551,8 @@
         </p:nvSpPr>
         <p:spPr>
           <a:xfrm>
-            <a:off x="566928" y="3639312"/>
-            <a:ext cx="3547872" cy="658368"/>
+            <a:off x="9070848" y="1463040"/>
+            <a:ext cx="2633472" cy="658368"/>
           </a:xfrm>
           <a:prstGeom prst="rect">
             <a:avLst/>
@@ -43610,7 +43576,7 @@
                 <a:ea typeface="Malgun Gothic" pitchFamily="34" charset="-122"/>
                 <a:cs typeface="Malgun Gothic" pitchFamily="34" charset="-120"/>
               </a:rPr>
-              <a:t>[  ]</a:t>
+              <a:t>25두</a:t>
             </a:r>
             <a:endParaRPr lang="en-US" sz="3200" dirty="0"/>
           </a:p>
@@ -43624,8 +43590,8 @@
         </p:nvSpPr>
         <p:spPr>
           <a:xfrm>
-            <a:off x="658368" y="4315968"/>
-            <a:ext cx="3364992" cy="987552"/>
+            <a:off x="9162288" y="2139696"/>
+            <a:ext cx="2450592" cy="667512"/>
           </a:xfrm>
           <a:prstGeom prst="rect">
             <a:avLst/>
@@ -43649,27 +43615,10 @@
                 <a:ea typeface="Malgun Gothic" pitchFamily="34" charset="-122"/>
                 <a:cs typeface="Malgun Gothic" pitchFamily="34" charset="-120"/>
               </a:rPr>
-              <a:t>유가공장 처리 용량</a:t>
+              <a:t>송아지 · 육성우</a:t>
             </a:r>
             <a:endParaRPr lang="en-US" sz="1150" dirty="0"/>
           </a:p>
-          <a:p>
-            <a:pPr algn="ctr" indent="0" marL="0">
-              <a:buNone/>
-            </a:pPr>
-            <a:r>
-              <a:rPr lang="en-US" sz="1150" dirty="0">
-                <a:solidFill>
-                  <a:srgbClr val="5E6B5F"/>
-                </a:solidFill>
-                <a:latin typeface="Malgun Gothic" pitchFamily="34" charset="0"/>
-                <a:ea typeface="Malgun Gothic" pitchFamily="34" charset="-122"/>
-                <a:cs typeface="Malgun Gothic" pitchFamily="34" charset="-120"/>
-              </a:rPr>
-              <a:t>(일 처리 [  ] L)</a:t>
-            </a:r>
-            <a:endParaRPr lang="en-US" sz="1150" dirty="0"/>
-          </a:p>
         </p:txBody>
       </p:sp>
       <p:sp>
@@ -43680,16 +43629,16 @@
         </p:nvSpPr>
         <p:spPr>
           <a:xfrm>
-            <a:off x="4315968" y="3474720"/>
-            <a:ext cx="3547872" cy="1920240"/>
+            <a:off x="566928" y="3127248"/>
+            <a:ext cx="3547872" cy="1600200"/>
           </a:xfrm>
           <a:prstGeom prst="roundRect">
             <a:avLst>
-              <a:gd name="adj" fmla="val 4762"/>
+              <a:gd name="adj" fmla="val 5714"/>
             </a:avLst>
           </a:prstGeom>
           <a:solidFill>
-            <a:srgbClr val="EEF4E9"/>
+            <a:srgbClr val="F3F6F1"/>
           </a:solidFill>
           <a:ln/>
         </p:spPr>
@@ -43702,7 +43651,7 @@
         </p:nvSpPr>
         <p:spPr>
           <a:xfrm>
-            <a:off x="4315968" y="3639312"/>
+            <a:off x="566928" y="3291840"/>
             <a:ext cx="3547872" cy="658368"/>
           </a:xfrm>
           <a:prstGeom prst="rect">
@@ -43719,7 +43668,7 @@
               <a:buNone/>
             </a:pPr>
             <a:r>
-              <a:rPr lang="en-US" sz="3200" b="1" dirty="0">
+              <a:rPr lang="en-US" sz="3000" b="1" dirty="0">
                 <a:solidFill>
                   <a:srgbClr val="1E4420"/>
                 </a:solidFill>
@@ -43727,9 +43676,9 @@
                 <a:ea typeface="Malgun Gothic" pitchFamily="34" charset="-122"/>
                 <a:cs typeface="Malgun Gothic" pitchFamily="34" charset="-120"/>
               </a:rPr>
-              <a:t>6종</a:t>
-            </a:r>
-            <a:endParaRPr lang="en-US" sz="3200" dirty="0"/>
+              <a:t>2,000㎡</a:t>
+            </a:r>
+            <a:endParaRPr lang="en-US" sz="3000" dirty="0"/>
           </a:p>
         </p:txBody>
       </p:sp>
@@ -43741,8 +43690,8 @@
         </p:nvSpPr>
         <p:spPr>
           <a:xfrm>
-            <a:off x="4407408" y="4315968"/>
-            <a:ext cx="3364992" cy="987552"/>
+            <a:off x="658368" y="3968496"/>
+            <a:ext cx="3364992" cy="667512"/>
           </a:xfrm>
           <a:prstGeom prst="rect">
             <a:avLst/>
@@ -43766,44 +43715,10 @@
                 <a:ea typeface="Malgun Gothic" pitchFamily="34" charset="-122"/>
                 <a:cs typeface="Malgun Gothic" pitchFamily="34" charset="-120"/>
               </a:rPr>
-              <a:t>제품 라인업</a:t>
+              <a:t>축사 면적</a:t>
             </a:r>
             <a:endParaRPr lang="en-US" sz="1150" dirty="0"/>
           </a:p>
-          <a:p>
-            <a:pPr algn="ctr" indent="0" marL="0">
-              <a:buNone/>
-            </a:pPr>
-            <a:r>
-              <a:rPr lang="en-US" sz="1150" dirty="0">
-                <a:solidFill>
-                  <a:srgbClr val="5E6B5F"/>
-                </a:solidFill>
-                <a:latin typeface="Malgun Gothic" pitchFamily="34" charset="0"/>
-                <a:ea typeface="Malgun Gothic" pitchFamily="34" charset="-122"/>
-                <a:cs typeface="Malgun Gothic" pitchFamily="34" charset="-120"/>
-              </a:rPr>
-              <a:t>우유·요거트·그릭·카이막</a:t>
-            </a:r>
-            <a:endParaRPr lang="en-US" sz="1150" dirty="0"/>
-          </a:p>
-          <a:p>
-            <a:pPr algn="ctr" indent="0" marL="0">
-              <a:buNone/>
-            </a:pPr>
-            <a:r>
-              <a:rPr lang="en-US" sz="1150" dirty="0">
-                <a:solidFill>
-                  <a:srgbClr val="5E6B5F"/>
-                </a:solidFill>
-                <a:latin typeface="Malgun Gothic" pitchFamily="34" charset="0"/>
-                <a:ea typeface="Malgun Gothic" pitchFamily="34" charset="-122"/>
-                <a:cs typeface="Malgun Gothic" pitchFamily="34" charset="-120"/>
-              </a:rPr>
-              <a:t>아이스크림·밀크티</a:t>
-            </a:r>
-            <a:endParaRPr lang="en-US" sz="1150" dirty="0"/>
-          </a:p>
         </p:txBody>
       </p:sp>
       <p:sp>
@@ -43814,16 +43729,16 @@
         </p:nvSpPr>
         <p:spPr>
           <a:xfrm>
-            <a:off x="8065008" y="3474720"/>
-            <a:ext cx="3547872" cy="1920240"/>
+            <a:off x="4315968" y="3127248"/>
+            <a:ext cx="3547872" cy="1600200"/>
           </a:xfrm>
           <a:prstGeom prst="roundRect">
             <a:avLst>
-              <a:gd name="adj" fmla="val 4762"/>
+              <a:gd name="adj" fmla="val 5714"/>
             </a:avLst>
           </a:prstGeom>
           <a:solidFill>
-            <a:srgbClr val="EEF4E9"/>
+            <a:srgbClr val="F3F6F1"/>
           </a:solidFill>
           <a:ln/>
         </p:spPr>
@@ -43836,7 +43751,7 @@
         </p:nvSpPr>
         <p:spPr>
           <a:xfrm>
-            <a:off x="8065008" y="3639312"/>
+            <a:off x="4315968" y="3291840"/>
             <a:ext cx="3547872" cy="658368"/>
           </a:xfrm>
           <a:prstGeom prst="rect">
@@ -43853,7 +43768,7 @@
               <a:buNone/>
             </a:pPr>
             <a:r>
-              <a:rPr lang="en-US" sz="3200" b="1" dirty="0">
+              <a:rPr lang="en-US" sz="3000" b="1" dirty="0">
                 <a:solidFill>
                   <a:srgbClr val="1E4420"/>
                 </a:solidFill>
@@ -43861,9 +43776,9 @@
                 <a:ea typeface="Malgun Gothic" pitchFamily="34" charset="-122"/>
                 <a:cs typeface="Malgun Gothic" pitchFamily="34" charset="-120"/>
               </a:rPr>
-              <a:t>D2C</a:t>
-            </a:r>
-            <a:endParaRPr lang="en-US" sz="3200" dirty="0"/>
+              <a:t>450㎡</a:t>
+            </a:r>
+            <a:endParaRPr lang="en-US" sz="3000" dirty="0"/>
           </a:p>
         </p:txBody>
       </p:sp>
@@ -43875,8 +43790,8 @@
         </p:nvSpPr>
         <p:spPr>
           <a:xfrm>
-            <a:off x="8156448" y="4315968"/>
-            <a:ext cx="3364992" cy="987552"/>
+            <a:off x="4407408" y="3968496"/>
+            <a:ext cx="3364992" cy="667512"/>
           </a:xfrm>
           <a:prstGeom prst="rect">
             <a:avLst/>
@@ -43900,15 +43815,98 @@
                 <a:ea typeface="Malgun Gothic" pitchFamily="34" charset="-122"/>
                 <a:cs typeface="Malgun Gothic" pitchFamily="34" charset="-120"/>
               </a:rPr>
-              <a:t>주 판매채널</a:t>
+              <a:t>퇴비장 면적</a:t>
             </a:r>
             <a:endParaRPr lang="en-US" sz="1150" dirty="0"/>
           </a:p>
+        </p:txBody>
+      </p:sp>
+      <p:sp>
+        <p:nvSpPr>
+          <p:cNvPr id="22" name="Shape 20"/>
+          <p:cNvSpPr/>
+          <p:nvPr/>
+        </p:nvSpPr>
+        <p:spPr>
+          <a:xfrm>
+            <a:off x="8065008" y="3127248"/>
+            <a:ext cx="3547872" cy="1600200"/>
+          </a:xfrm>
+          <a:prstGeom prst="roundRect">
+            <a:avLst>
+              <a:gd name="adj" fmla="val 5714"/>
+            </a:avLst>
+          </a:prstGeom>
+          <a:solidFill>
+            <a:srgbClr val="F3F6F1"/>
+          </a:solidFill>
+          <a:ln/>
+        </p:spPr>
+      </p:sp>
+      <p:sp>
+        <p:nvSpPr>
+          <p:cNvPr id="23" name="Text 21"/>
+          <p:cNvSpPr/>
+          <p:nvPr/>
+        </p:nvSpPr>
+        <p:spPr>
+          <a:xfrm>
+            <a:off x="8065008" y="3291840"/>
+            <a:ext cx="3547872" cy="658368"/>
+          </a:xfrm>
+          <a:prstGeom prst="rect">
+            <a:avLst/>
+          </a:prstGeom>
+          <a:noFill/>
+          <a:ln/>
+        </p:spPr>
+        <p:txBody>
+          <a:bodyPr wrap="square" lIns="0" tIns="0" rIns="0" bIns="0" rtlCol="0" anchor="ctr"/>
+          <a:lstStyle/>
           <a:p>
             <a:pPr algn="ctr" indent="0" marL="0">
               <a:buNone/>
             </a:pPr>
             <a:r>
+              <a:rPr lang="en-US" sz="3000" b="1" dirty="0">
+                <a:solidFill>
+                  <a:srgbClr val="1E4420"/>
+                </a:solidFill>
+                <a:latin typeface="Malgun Gothic" pitchFamily="34" charset="0"/>
+                <a:ea typeface="Malgun Gothic" pitchFamily="34" charset="-122"/>
+                <a:cs typeface="Malgun Gothic" pitchFamily="34" charset="-120"/>
+              </a:rPr>
+              <a:t>시간당 500L</a:t>
+            </a:r>
+            <a:endParaRPr lang="en-US" sz="3000" dirty="0"/>
+          </a:p>
+        </p:txBody>
+      </p:sp>
+      <p:sp>
+        <p:nvSpPr>
+          <p:cNvPr id="24" name="Text 22"/>
+          <p:cNvSpPr/>
+          <p:nvPr/>
+        </p:nvSpPr>
+        <p:spPr>
+          <a:xfrm>
+            <a:off x="8156448" y="3968496"/>
+            <a:ext cx="3364992" cy="667512"/>
+          </a:xfrm>
+          <a:prstGeom prst="rect">
+            <a:avLst/>
+          </a:prstGeom>
+          <a:noFill/>
+          <a:ln/>
+        </p:spPr>
+        <p:txBody>
+          <a:bodyPr wrap="square" lIns="0" tIns="0" rIns="0" bIns="0" rtlCol="0" anchor="t"/>
+          <a:lstStyle/>
+          <a:p>
+            <a:pPr algn="ctr" indent="0" marL="0">
+              <a:buNone/>
+            </a:pPr>
+            <a:r>
               <a:rPr lang="en-US" sz="1150" dirty="0">
                 <a:solidFill>
                   <a:srgbClr val="5E6B5F"/>
@@ -43917,65 +43915,132 @@
                 <a:ea typeface="Malgun Gothic" pitchFamily="34" charset="-122"/>
                 <a:cs typeface="Malgun Gothic" pitchFamily="34" charset="-120"/>
               </a:rPr>
-              <a:t>shop.a2jerseymilk.com</a:t>
+              <a:t>유가공장 처리 용량</a:t>
             </a:r>
             <a:endParaRPr lang="en-US" sz="1150" dirty="0"/>
           </a:p>
-          <a:p>
-            <a:pPr algn="ctr" indent="0" marL="0">
-              <a:buNone/>
-            </a:pPr>
-            <a:r>
-              <a:rPr lang="en-US" sz="1150" dirty="0">
-                <a:solidFill>
-                  <a:srgbClr val="5E6B5F"/>
-                </a:solidFill>
-                <a:latin typeface="Malgun Gothic" pitchFamily="34" charset="0"/>
-                <a:ea typeface="Malgun Gothic" pitchFamily="34" charset="-122"/>
-                <a:cs typeface="Malgun Gothic" pitchFamily="34" charset="-120"/>
-              </a:rPr>
-              <a:t>+ 정기구독 + B2B</a:t>
-            </a:r>
-            <a:endParaRPr lang="en-US" sz="1150" dirty="0"/>
-          </a:p>
-        </p:txBody>
-      </p:sp>
-      <p:sp>
-        <p:nvSpPr>
-          <p:cNvPr id="22" name="Text 20"/>
-          <p:cNvSpPr/>
-          <p:nvPr/>
-        </p:nvSpPr>
-        <p:spPr>
-          <a:xfrm>
-            <a:off x="566928" y="6327648"/>
-            <a:ext cx="11064240" cy="274320"/>
-          </a:xfrm>
-          <a:prstGeom prst="rect">
-            <a:avLst/>
-          </a:prstGeom>
-          <a:noFill/>
-          <a:ln/>
-        </p:spPr>
-        <p:txBody>
-          <a:bodyPr wrap="square" lIns="0" tIns="0" rIns="0" bIns="0" rtlCol="0" anchor="ctr"/>
-          <a:lstStyle/>
-          <a:p>
-            <a:pPr indent="0" marL="0">
-              <a:buNone/>
-            </a:pPr>
-            <a:r>
-              <a:rPr lang="en-US" sz="1000" dirty="0">
-                <a:solidFill>
-                  <a:srgbClr val="5E6B5F"/>
-                </a:solidFill>
-                <a:latin typeface="Malgun Gothic" pitchFamily="34" charset="0"/>
-                <a:ea typeface="Malgun Gothic" pitchFamily="34" charset="-122"/>
-                <a:cs typeface="Malgun Gothic" pitchFamily="34" charset="-120"/>
-              </a:rPr>
-              <a:t>※ [  ] 표시는 발표 직전 목장 실측치로 채워 넣을 항목입니다.</a:t>
-            </a:r>
-            <a:endParaRPr lang="en-US" sz="1000" dirty="0"/>
+        </p:txBody>
+      </p:sp>
+      <p:sp>
+        <p:nvSpPr>
+          <p:cNvPr id="25" name="Shape 23"/>
+          <p:cNvSpPr/>
+          <p:nvPr/>
+        </p:nvSpPr>
+        <p:spPr>
+          <a:xfrm>
+            <a:off x="566928" y="4956048"/>
+            <a:ext cx="11064240" cy="1188720"/>
+          </a:xfrm>
+          <a:prstGeom prst="roundRect">
+            <a:avLst>
+              <a:gd name="adj" fmla="val 7692"/>
+            </a:avLst>
+          </a:prstGeom>
+          <a:solidFill>
+            <a:srgbClr val="13301F"/>
+          </a:solidFill>
+          <a:ln/>
+        </p:spPr>
+      </p:sp>
+      <p:sp>
+        <p:nvSpPr>
+          <p:cNvPr id="26" name="Text 24"/>
+          <p:cNvSpPr/>
+          <p:nvPr/>
+        </p:nvSpPr>
+        <p:spPr>
+          <a:xfrm>
+            <a:off x="868680" y="5102352"/>
+            <a:ext cx="10424160" cy="329184"/>
+          </a:xfrm>
+          <a:prstGeom prst="rect">
+            <a:avLst/>
+          </a:prstGeom>
+          <a:noFill/>
+          <a:ln/>
+        </p:spPr>
+        <p:txBody>
+          <a:bodyPr wrap="square" lIns="0" tIns="0" rIns="0" bIns="0" rtlCol="0" anchor="t"/>
+          <a:lstStyle/>
+          <a:p>
+            <a:pPr algn="l" indent="0" marL="0">
+              <a:buNone/>
+            </a:pPr>
+            <a:r>
+              <a:rPr lang="en-US" sz="1400" b="1" dirty="0">
+                <a:solidFill>
+                  <a:srgbClr val="E9C79A"/>
+                </a:solidFill>
+                <a:latin typeface="Malgun Gothic" pitchFamily="34" charset="0"/>
+                <a:ea typeface="Malgun Gothic" pitchFamily="34" charset="-122"/>
+                <a:cs typeface="Malgun Gothic" pitchFamily="34" charset="-120"/>
+              </a:rPr>
+              <a:t>규모로 읽지 마시고, 구조로 봐주십시오</a:t>
+            </a:r>
+            <a:endParaRPr lang="en-US" sz="1400" dirty="0"/>
+          </a:p>
+        </p:txBody>
+      </p:sp>
+      <p:sp>
+        <p:nvSpPr>
+          <p:cNvPr id="27" name="Text 25"/>
+          <p:cNvSpPr/>
+          <p:nvPr/>
+        </p:nvSpPr>
+        <p:spPr>
+          <a:xfrm>
+            <a:off x="868680" y="5449824"/>
+            <a:ext cx="10424160" cy="603504"/>
+          </a:xfrm>
+          <a:prstGeom prst="rect">
+            <a:avLst/>
+          </a:prstGeom>
+          <a:noFill/>
+          <a:ln/>
+        </p:spPr>
+        <p:txBody>
+          <a:bodyPr wrap="square" lIns="0" tIns="0" rIns="0" bIns="0" rtlCol="0" anchor="t"/>
+          <a:lstStyle/>
+          <a:p>
+            <a:pPr algn="l" indent="0" marL="0">
+              <a:lnSpc>
+                <a:spcPts val="1900"/>
+              </a:lnSpc>
+              <a:buNone/>
+            </a:pPr>
+            <a:r>
+              <a:rPr lang="en-US" sz="1250" dirty="0">
+                <a:solidFill>
+                  <a:srgbClr val="FFFFFF"/>
+                </a:solidFill>
+                <a:latin typeface="Malgun Gothic" pitchFamily="34" charset="0"/>
+                <a:ea typeface="Malgun Gothic" pitchFamily="34" charset="-122"/>
+                <a:cs typeface="Malgun Gothic" pitchFamily="34" charset="-120"/>
+              </a:rPr>
+              <a:t>착유 35두 규모입니다. 이 두수로 원유 납품만 해서는 성립하기 어렵습니다.</a:t>
+            </a:r>
+            <a:endParaRPr lang="en-US" sz="1250" dirty="0"/>
+          </a:p>
+          <a:p>
+            <a:pPr algn="l" indent="0" marL="0">
+              <a:lnSpc>
+                <a:spcPts val="1900"/>
+              </a:lnSpc>
+              <a:buNone/>
+            </a:pPr>
+            <a:r>
+              <a:rPr lang="en-US" sz="1250" dirty="0">
+                <a:solidFill>
+                  <a:srgbClr val="FFFFFF"/>
+                </a:solidFill>
+                <a:latin typeface="Malgun Gothic" pitchFamily="34" charset="0"/>
+                <a:ea typeface="Malgun Gothic" pitchFamily="34" charset="-122"/>
+                <a:cs typeface="Malgun Gothic" pitchFamily="34" charset="-120"/>
+              </a:rPr>
+              <a:t>저지 단일 품종 + 자체 유가공(시간당 500L) + 퇴비장 450㎡의 순환 구조가 함께 있어야 돌아가는 모델입니다.</a:t>
+            </a:r>
+            <a:endParaRPr lang="en-US" sz="1250" dirty="0"/>
           </a:p>
         </p:txBody>
       </p:sp>

</xml_diff>